<commit_message>
fix: unique Unsplash photo IDs and consistent Uzbek okina/tutuq orthography
- give slides 3 and 10 distinct Unsplash photo IDs so no ID is reused
- normalize in-word apostrophes in slide text and README: use okina U+02BB
  for oʻ/gʻ and tutuq belgisi U+02BC for glottal stops (taʼsiri, Eʼtibor...)
- verify_presentation.py now also asserts all 10 Unsplash photo IDs are distinct
</commit_message>
<xml_diff>
--- a/Kompyuterlar_qizishi_va_sovishi.pptx
+++ b/Kompyuterlar_qizishi_va_sovishi.pptx
@@ -291,7 +291,7 @@
                 <a:latin typeface="Times New Roman" panose="02020603050405020304" pitchFamily="18" charset="0"/>
                 <a:cs typeface="Times New Roman" panose="02020603050405020304" pitchFamily="18" charset="0"/>
               </a:rPr>
-              <a:t>E'tiboringiz uchun rahmat!</a:t>
+              <a:t>Eʼtiboringiz uchun rahmat!</a:t>
             </a:r>
           </a:p>
         </p:txBody>
@@ -367,7 +367,7 @@
                 <a:latin typeface="Times New Roman" panose="02020603050405020304" pitchFamily="18" charset="0"/>
                 <a:cs typeface="Times New Roman" panose="02020603050405020304" pitchFamily="18" charset="0"/>
               </a:rPr>
-              <a:t>Rasm (Unsplash): https://unsplash.com/photos/a-glowing-computer-cpu-on-a-dark-background-mcSDtbWXUZU</a:t>
+              <a:t>Rasm (Unsplash): https://unsplash.com/photos/a-glowing-computer-cpu-on-a-dark-background-pfR18JNEl8s</a:t>
             </a:r>
           </a:p>
         </p:txBody>
@@ -510,7 +510,7 @@
                 <a:latin typeface="Times New Roman" panose="02020603050405020304" pitchFamily="18" charset="0"/>
                 <a:cs typeface="Times New Roman" panose="02020603050405020304" pitchFamily="18" charset="0"/>
               </a:rPr>
-              <a:t>Kompyuter qiziganda nima yuz beradi: trottling (throttling) va uning ishlash tezligiga ta'siri.</a:t>
+              <a:t>Kompyuter qiziganda nima yuz beradi: trottling (throttling) va uning ishlash tezligiga taʼsiri.</a:t>
             </a:r>
           </a:p>
           <a:p>
@@ -539,7 +539,7 @@
                 <a:latin typeface="Times New Roman" panose="02020603050405020304" pitchFamily="18" charset="0"/>
                 <a:cs typeface="Times New Roman" panose="02020603050405020304" pitchFamily="18" charset="0"/>
               </a:rPr>
-              <a:t>Radiatorlar, termopastaning vazifasi, kulerlar yordamida havoni so'rib olish va haydash.</a:t>
+              <a:t>Radiatorlar, termopastaning vazifasi, kulerlar yordamida havoni soʻrib olish va haydash.</a:t>
             </a:r>
           </a:p>
           <a:p>
@@ -690,7 +690,7 @@
                 <a:latin typeface="Times New Roman" panose="02020603050405020304" pitchFamily="18" charset="0"/>
                 <a:cs typeface="Times New Roman" panose="02020603050405020304" pitchFamily="18" charset="0"/>
               </a:rPr>
-              <a:t>Zamonaviy protsessor milliardlab mayda tranzistorlardan iborat bo'lib, ular elektron kalitlar vazifasini bajaradi.</a:t>
+              <a:t>Zamonaviy protsessor milliardlab mayda tranzistorlardan iborat boʻlib, ular elektron kalitlar vazifasini bajaradi.</a:t>
             </a:r>
           </a:p>
           <a:p>
@@ -716,20 +716,20 @@
                 <a:latin typeface="Times New Roman" panose="02020603050405020304" pitchFamily="18" charset="0"/>
                 <a:cs typeface="Times New Roman" panose="02020603050405020304" pitchFamily="18" charset="0"/>
               </a:rPr>
-              <a:t>Tranzistorlarning ochilib-yopilishida yarimo'tkazgich materialning qarshiligi tufayli elektr energiyasining bir qismi issiqlikka aylanadi.</a:t>
-            </a:r>
-          </a:p>
-          <a:p>
-            <a:pPr marL="285750" indent="-285750">
-              <a:buFont typeface="Arial" pitchFamily="34" charset="0"/>
-              <a:buChar char="•"/>
-            </a:pPr>
-            <a:r>
-              <a:rPr lang="uz-UZ" sz="1600" dirty="0">
-                <a:latin typeface="Times New Roman" panose="02020603050405020304" pitchFamily="18" charset="0"/>
-                <a:cs typeface="Times New Roman" panose="02020603050405020304" pitchFamily="18" charset="0"/>
-              </a:rPr>
-              <a:t>Tranzistorlar soni va chastota (GHz) qancha yuqori bo'lsa, ajralib chiqadigan issiqlik ham shuncha ko'p bo'ladi.</a:t>
+              <a:t>Tranzistorlarning ochilib-yopilishida yarimoʻtkazgich materialning qarshiligi tufayli elektr energiyasining bir qismi issiqlikka aylanadi.</a:t>
+            </a:r>
+          </a:p>
+          <a:p>
+            <a:pPr marL="285750" indent="-285750">
+              <a:buFont typeface="Arial" pitchFamily="34" charset="0"/>
+              <a:buChar char="•"/>
+            </a:pPr>
+            <a:r>
+              <a:rPr lang="uz-UZ" sz="1600" dirty="0">
+                <a:latin typeface="Times New Roman" panose="02020603050405020304" pitchFamily="18" charset="0"/>
+                <a:cs typeface="Times New Roman" panose="02020603050405020304" pitchFamily="18" charset="0"/>
+              </a:rPr>
+              <a:t>Tranzistorlar soni va chastota (GHz) qancha yuqori boʻlsa, ajralib chiqadigan issiqlik ham shuncha koʻp boʻladi.</a:t>
             </a:r>
           </a:p>
           <a:p>
@@ -741,7 +741,7 @@
                 <a:latin typeface="Times New Roman" panose="02020603050405020304" pitchFamily="18" charset="0"/>
                 <a:cs typeface="Times New Roman" panose="02020603050405020304" pitchFamily="18" charset="0"/>
               </a:rPr>
-              <a:t>Rasm (Unsplash): https://unsplash.com/photos/macro-photography-of-black-circuit-board-FO7JIlwjOtU</a:t>
+              <a:t>Rasm (Unsplash): https://unsplash.com/photos/macro-photography-of-black-circuit-board-aQYgUYwnCsM</a:t>
             </a:r>
           </a:p>
         </p:txBody>
@@ -867,46 +867,46 @@
                 <a:latin typeface="Times New Roman" panose="02020603050405020304" pitchFamily="18" charset="0"/>
                 <a:cs typeface="Times New Roman" panose="02020603050405020304" pitchFamily="18" charset="0"/>
               </a:rPr>
-              <a:t>Bu yerda Q - ajralib chiqqan issiqlik miqdori, I - tok kuchi, R - o'tkazgich qarshiligi, t - vaqt.</a:t>
-            </a:r>
-          </a:p>
-          <a:p>
-            <a:pPr marL="285750" indent="-285750">
-              <a:buFont typeface="Arial" pitchFamily="34" charset="0"/>
-              <a:buChar char="•"/>
-            </a:pPr>
-            <a:r>
-              <a:rPr lang="uz-UZ" sz="1600" dirty="0">
-                <a:latin typeface="Times New Roman" panose="02020603050405020304" pitchFamily="18" charset="0"/>
-                <a:cs typeface="Times New Roman" panose="02020603050405020304" pitchFamily="18" charset="0"/>
-              </a:rPr>
-              <a:t>O'tkazgichdan tok o'tganda zaryadlangan zarralar atom panjarasi bilan to'qnashadi va energiyasining bir qismini issiqlik ko'rinishida yo'qotadi.</a:t>
-            </a:r>
-          </a:p>
-          <a:p>
-            <a:pPr marL="285750" indent="-285750">
-              <a:buFont typeface="Arial" pitchFamily="34" charset="0"/>
-              <a:buChar char="•"/>
-            </a:pPr>
-            <a:r>
-              <a:rPr lang="uz-UZ" sz="1600" dirty="0">
-                <a:latin typeface="Times New Roman" panose="02020603050405020304" pitchFamily="18" charset="0"/>
-                <a:cs typeface="Times New Roman" panose="02020603050405020304" pitchFamily="18" charset="0"/>
-              </a:rPr>
-              <a:t>Shu sababli protsessor qanchalik ko'p hisob-kitob bajarsa, tok kuchi (I) ortadi va ajralib chiqadigan issiqlik kvadratik ravishda ko'payadi.</a:t>
-            </a:r>
-          </a:p>
-          <a:p>
-            <a:pPr marL="285750" indent="-285750">
-              <a:buFont typeface="Arial" pitchFamily="34" charset="0"/>
-              <a:buChar char="•"/>
-            </a:pPr>
-            <a:r>
-              <a:rPr lang="uz-UZ" sz="1600" dirty="0">
-                <a:latin typeface="Times New Roman" panose="02020603050405020304" pitchFamily="18" charset="0"/>
-                <a:cs typeface="Times New Roman" panose="02020603050405020304" pitchFamily="18" charset="0"/>
-              </a:rPr>
-              <a:t>Ajralgan issiqlik vaqtida chiqarilmasa, kristall harorati xavfli darajaga ko'tariladi.</a:t>
+              <a:t>Bu yerda Q - ajralib chiqqan issiqlik miqdori, I - tok kuchi, R - oʻtkazgich qarshiligi, t - vaqt.</a:t>
+            </a:r>
+          </a:p>
+          <a:p>
+            <a:pPr marL="285750" indent="-285750">
+              <a:buFont typeface="Arial" pitchFamily="34" charset="0"/>
+              <a:buChar char="•"/>
+            </a:pPr>
+            <a:r>
+              <a:rPr lang="uz-UZ" sz="1600" dirty="0">
+                <a:latin typeface="Times New Roman" panose="02020603050405020304" pitchFamily="18" charset="0"/>
+                <a:cs typeface="Times New Roman" panose="02020603050405020304" pitchFamily="18" charset="0"/>
+              </a:rPr>
+              <a:t>Oʻtkazgichdan tok oʻtganda zaryadlangan zarralar atom panjarasi bilan toʻqnashadi va energiyasining bir qismini issiqlik koʻrinishida yoʻqotadi.</a:t>
+            </a:r>
+          </a:p>
+          <a:p>
+            <a:pPr marL="285750" indent="-285750">
+              <a:buFont typeface="Arial" pitchFamily="34" charset="0"/>
+              <a:buChar char="•"/>
+            </a:pPr>
+            <a:r>
+              <a:rPr lang="uz-UZ" sz="1600" dirty="0">
+                <a:latin typeface="Times New Roman" panose="02020603050405020304" pitchFamily="18" charset="0"/>
+                <a:cs typeface="Times New Roman" panose="02020603050405020304" pitchFamily="18" charset="0"/>
+              </a:rPr>
+              <a:t>Shu sababli protsessor qanchalik koʻp hisob-kitob bajarsa, tok kuchi (I) ortadi va ajralib chiqadigan issiqlik kvadratik ravishda koʻpayadi.</a:t>
+            </a:r>
+          </a:p>
+          <a:p>
+            <a:pPr marL="285750" indent="-285750">
+              <a:buFont typeface="Arial" pitchFamily="34" charset="0"/>
+              <a:buChar char="•"/>
+            </a:pPr>
+            <a:r>
+              <a:rPr lang="uz-UZ" sz="1600" dirty="0">
+                <a:latin typeface="Times New Roman" panose="02020603050405020304" pitchFamily="18" charset="0"/>
+                <a:cs typeface="Times New Roman" panose="02020603050405020304" pitchFamily="18" charset="0"/>
+              </a:rPr>
+              <a:t>Ajralgan issiqlik vaqtida chiqarilmasa, kristall harorati xavfli darajaga koʻtariladi.</a:t>
             </a:r>
           </a:p>
           <a:p>
@@ -1054,20 +1054,20 @@
                 <a:latin typeface="Times New Roman" panose="02020603050405020304" pitchFamily="18" charset="0"/>
                 <a:cs typeface="Times New Roman" panose="02020603050405020304" pitchFamily="18" charset="0"/>
               </a:rPr>
-              <a:t>Haddan tashqari qizish natijasida kompyuter o'z-o'zidan o'chib qolishi yoki qotib qolishi mumkin.</a:t>
-            </a:r>
-          </a:p>
-          <a:p>
-            <a:pPr marL="285750" indent="-285750">
-              <a:buFont typeface="Arial" pitchFamily="34" charset="0"/>
-              <a:buChar char="•"/>
-            </a:pPr>
-            <a:r>
-              <a:rPr lang="uz-UZ" sz="1600" dirty="0">
-                <a:latin typeface="Times New Roman" panose="02020603050405020304" pitchFamily="18" charset="0"/>
-                <a:cs typeface="Times New Roman" panose="02020603050405020304" pitchFamily="18" charset="0"/>
-              </a:rPr>
-              <a:t>Shuning uchun protsessorda harorat datchiklari bo'lib, ular haroratni doimiy nazorat qilib turadi.</a:t>
+              <a:t>Haddan tashqari qizish natijasida kompyuter oʻz-oʻzidan oʻchib qolishi yoki qotib qolishi mumkin.</a:t>
+            </a:r>
+          </a:p>
+          <a:p>
+            <a:pPr marL="285750" indent="-285750">
+              <a:buFont typeface="Arial" pitchFamily="34" charset="0"/>
+              <a:buChar char="•"/>
+            </a:pPr>
+            <a:r>
+              <a:rPr lang="uz-UZ" sz="1600" dirty="0">
+                <a:latin typeface="Times New Roman" panose="02020603050405020304" pitchFamily="18" charset="0"/>
+                <a:cs typeface="Times New Roman" panose="02020603050405020304" pitchFamily="18" charset="0"/>
+              </a:rPr>
+              <a:t>Shuning uchun protsessorda harorat datchiklari boʻlib, ular haroratni doimiy nazorat qilib turadi.</a:t>
             </a:r>
           </a:p>
           <a:p>
@@ -1176,33 +1176,33 @@
                 <a:latin typeface="Times New Roman" panose="02020603050405020304" pitchFamily="18" charset="0"/>
                 <a:cs typeface="Times New Roman" panose="02020603050405020304" pitchFamily="18" charset="0"/>
               </a:rPr>
-              <a:t>Himoya mexanizmi va uning tezlikka ta'siri</a:t>
-            </a:r>
-          </a:p>
-          <a:p>
-            <a:pPr marL="285750" indent="-285750">
-              <a:buFont typeface="Arial" pitchFamily="34" charset="0"/>
-              <a:buChar char="•"/>
-            </a:pPr>
-            <a:r>
-              <a:rPr lang="uz-UZ" sz="1600" dirty="0">
-                <a:latin typeface="Times New Roman" panose="02020603050405020304" pitchFamily="18" charset="0"/>
-                <a:cs typeface="Times New Roman" panose="02020603050405020304" pitchFamily="18" charset="0"/>
-              </a:rPr>
-              <a:t>Trottling - harorat xavfli chegaraga yetganda protsessor o'z ish chastotasini (tezligini) atayin pasaytirishi.</a:t>
-            </a:r>
-          </a:p>
-          <a:p>
-            <a:pPr marL="285750" indent="-285750">
-              <a:buFont typeface="Arial" pitchFamily="34" charset="0"/>
-              <a:buChar char="•"/>
-            </a:pPr>
-            <a:r>
-              <a:rPr lang="uz-UZ" sz="1600" dirty="0">
-                <a:latin typeface="Times New Roman" panose="02020603050405020304" pitchFamily="18" charset="0"/>
-                <a:cs typeface="Times New Roman" panose="02020603050405020304" pitchFamily="18" charset="0"/>
-              </a:rPr>
-              <a:t>Chastotaning pasayishi bilan tok kuchi kamayadi, natijada Joul-Lents qonuniga ko'ra ajralib chiqadigan issiqlik ham kamayadi.</a:t>
+              <a:t>Himoya mexanizmi va uning tezlikka taʼsiri</a:t>
+            </a:r>
+          </a:p>
+          <a:p>
+            <a:pPr marL="285750" indent="-285750">
+              <a:buFont typeface="Arial" pitchFamily="34" charset="0"/>
+              <a:buChar char="•"/>
+            </a:pPr>
+            <a:r>
+              <a:rPr lang="uz-UZ" sz="1600" dirty="0">
+                <a:latin typeface="Times New Roman" panose="02020603050405020304" pitchFamily="18" charset="0"/>
+                <a:cs typeface="Times New Roman" panose="02020603050405020304" pitchFamily="18" charset="0"/>
+              </a:rPr>
+              <a:t>Trottling - harorat xavfli chegaraga yetganda protsessor oʻz ish chastotasini (tezligini) atayin pasaytirishi.</a:t>
+            </a:r>
+          </a:p>
+          <a:p>
+            <a:pPr marL="285750" indent="-285750">
+              <a:buFont typeface="Arial" pitchFamily="34" charset="0"/>
+              <a:buChar char="•"/>
+            </a:pPr>
+            <a:r>
+              <a:rPr lang="uz-UZ" sz="1600" dirty="0">
+                <a:latin typeface="Times New Roman" panose="02020603050405020304" pitchFamily="18" charset="0"/>
+                <a:cs typeface="Times New Roman" panose="02020603050405020304" pitchFamily="18" charset="0"/>
+              </a:rPr>
+              <a:t>Chastotaning pasayishi bilan tok kuchi kamayadi, natijada Joul-Lents qonuniga koʻra ajralib chiqadigan issiqlik ham kamayadi.</a:t>
             </a:r>
           </a:p>
           <a:p>
@@ -1228,7 +1228,7 @@
                 <a:latin typeface="Times New Roman" panose="02020603050405020304" pitchFamily="18" charset="0"/>
                 <a:cs typeface="Times New Roman" panose="02020603050405020304" pitchFamily="18" charset="0"/>
               </a:rPr>
-              <a:t>Natijada o'yinlar va og'ir dasturlarda "sekinlashish" (lag) seziladi. Yaxshi sovutish trottlingni oldini oladi.</a:t>
+              <a:t>Natijada oʻyinlar va ogʻir dasturlarda "sekinlashish" (lag) seziladi. Yaxshi sovutish trottlingni oldini oladi.</a:t>
             </a:r>
           </a:p>
           <a:p>
@@ -1350,46 +1350,46 @@
                 <a:latin typeface="Times New Roman" panose="02020603050405020304" pitchFamily="18" charset="0"/>
                 <a:cs typeface="Times New Roman" panose="02020603050405020304" pitchFamily="18" charset="0"/>
               </a:rPr>
-              <a:t>Radiator (issiqlik tarqatgich) - ko'p sonli metall qanotlardan iborat bo'lib, issiqlik almashinuv yuzasini kengaytiradi.</a:t>
-            </a:r>
-          </a:p>
-          <a:p>
-            <a:pPr marL="285750" indent="-285750">
-              <a:buFont typeface="Arial" pitchFamily="34" charset="0"/>
-              <a:buChar char="•"/>
-            </a:pPr>
-            <a:r>
-              <a:rPr lang="uz-UZ" sz="1600" dirty="0">
-                <a:latin typeface="Times New Roman" panose="02020603050405020304" pitchFamily="18" charset="0"/>
-                <a:cs typeface="Times New Roman" panose="02020603050405020304" pitchFamily="18" charset="0"/>
-              </a:rPr>
-              <a:t>Mis va alyuminiy yuqori issiqlik o'tkazuvchanligi tufayli radiatorlar uchun asosiy material hisoblanadi.</a:t>
-            </a:r>
-          </a:p>
-          <a:p>
-            <a:pPr marL="285750" indent="-285750">
-              <a:buFont typeface="Arial" pitchFamily="34" charset="0"/>
-              <a:buChar char="•"/>
-            </a:pPr>
-            <a:r>
-              <a:rPr lang="uz-UZ" sz="1600" dirty="0">
-                <a:latin typeface="Times New Roman" panose="02020603050405020304" pitchFamily="18" charset="0"/>
-                <a:cs typeface="Times New Roman" panose="02020603050405020304" pitchFamily="18" charset="0"/>
-              </a:rPr>
-              <a:t>Termopasta protsessor va radiator orasidagi mikroskopik havo bo'shliqlarini to'ldiradi; havo issiqlikni yomon o'tkazadi, pasta esa aloqani yaxshilaydi.</a:t>
-            </a:r>
-          </a:p>
-          <a:p>
-            <a:pPr marL="285750" indent="-285750">
-              <a:buFont typeface="Arial" pitchFamily="34" charset="0"/>
-              <a:buChar char="•"/>
-            </a:pPr>
-            <a:r>
-              <a:rPr lang="uz-UZ" sz="1600" dirty="0">
-                <a:latin typeface="Times New Roman" panose="02020603050405020304" pitchFamily="18" charset="0"/>
-                <a:cs typeface="Times New Roman" panose="02020603050405020304" pitchFamily="18" charset="0"/>
-              </a:rPr>
-              <a:t>Shunday qilib issiqlik issiqlik o'tkazuvchanlik orqali kristalldan radiatorga samarali uzatiladi.</a:t>
+              <a:t>Radiator (issiqlik tarqatgich) - koʻp sonli metall qanotlardan iborat boʻlib, issiqlik almashinuv yuzasini kengaytiradi.</a:t>
+            </a:r>
+          </a:p>
+          <a:p>
+            <a:pPr marL="285750" indent="-285750">
+              <a:buFont typeface="Arial" pitchFamily="34" charset="0"/>
+              <a:buChar char="•"/>
+            </a:pPr>
+            <a:r>
+              <a:rPr lang="uz-UZ" sz="1600" dirty="0">
+                <a:latin typeface="Times New Roman" panose="02020603050405020304" pitchFamily="18" charset="0"/>
+                <a:cs typeface="Times New Roman" panose="02020603050405020304" pitchFamily="18" charset="0"/>
+              </a:rPr>
+              <a:t>Mis va alyuminiy yuqori issiqlik oʻtkazuvchanligi tufayli radiatorlar uchun asosiy material hisoblanadi.</a:t>
+            </a:r>
+          </a:p>
+          <a:p>
+            <a:pPr marL="285750" indent="-285750">
+              <a:buFont typeface="Arial" pitchFamily="34" charset="0"/>
+              <a:buChar char="•"/>
+            </a:pPr>
+            <a:r>
+              <a:rPr lang="uz-UZ" sz="1600" dirty="0">
+                <a:latin typeface="Times New Roman" panose="02020603050405020304" pitchFamily="18" charset="0"/>
+                <a:cs typeface="Times New Roman" panose="02020603050405020304" pitchFamily="18" charset="0"/>
+              </a:rPr>
+              <a:t>Termopasta protsessor va radiator orasidagi mikroskopik havo boʻshliqlarini toʻldiradi; havo issiqlikni yomon oʻtkazadi, pasta esa aloqani yaxshilaydi.</a:t>
+            </a:r>
+          </a:p>
+          <a:p>
+            <a:pPr marL="285750" indent="-285750">
+              <a:buFont typeface="Arial" pitchFamily="34" charset="0"/>
+              <a:buChar char="•"/>
+            </a:pPr>
+            <a:r>
+              <a:rPr lang="uz-UZ" sz="1600" dirty="0">
+                <a:latin typeface="Times New Roman" panose="02020603050405020304" pitchFamily="18" charset="0"/>
+                <a:cs typeface="Times New Roman" panose="02020603050405020304" pitchFamily="18" charset="0"/>
+              </a:rPr>
+              <a:t>Shunday qilib issiqlik issiqlik oʻtkazuvchanlik orqali kristalldan radiatorga samarali uzatiladi.</a:t>
             </a:r>
           </a:p>
           <a:p>
@@ -1498,7 +1498,7 @@
                 <a:latin typeface="Times New Roman" panose="02020603050405020304" pitchFamily="18" charset="0"/>
                 <a:cs typeface="Times New Roman" panose="02020603050405020304" pitchFamily="18" charset="0"/>
               </a:rPr>
-              <a:t>Havoni so'rib olish va haydash jarayoni</a:t>
+              <a:t>Havoni soʻrib olish va haydash jarayoni</a:t>
             </a:r>
           </a:p>
           <a:p>
@@ -1524,20 +1524,20 @@
                 <a:latin typeface="Times New Roman" panose="02020603050405020304" pitchFamily="18" charset="0"/>
                 <a:cs typeface="Times New Roman" panose="02020603050405020304" pitchFamily="18" charset="0"/>
               </a:rPr>
-              <a:t>Bu jarayon konveksiya deb ataladi: harakatlanayotgan havo issiqlikni o'zi bilan olib ketadi.</a:t>
-            </a:r>
-          </a:p>
-          <a:p>
-            <a:pPr marL="285750" indent="-285750">
-              <a:buFont typeface="Arial" pitchFamily="34" charset="0"/>
-              <a:buChar char="•"/>
-            </a:pPr>
-            <a:r>
-              <a:rPr lang="uz-UZ" sz="1600" dirty="0">
-                <a:latin typeface="Times New Roman" panose="02020603050405020304" pitchFamily="18" charset="0"/>
-                <a:cs typeface="Times New Roman" panose="02020603050405020304" pitchFamily="18" charset="0"/>
-              </a:rPr>
-              <a:t>Korpusda havo balansi muhim: oldingi ventilyatorlar salqin havoni so'rib oladi, orqadagilar esa issiq havoni haydaydi.</a:t>
+              <a:t>Bu jarayon konveksiya deb ataladi: harakatlanayotgan havo issiqlikni oʻzi bilan olib ketadi.</a:t>
+            </a:r>
+          </a:p>
+          <a:p>
+            <a:pPr marL="285750" indent="-285750">
+              <a:buFont typeface="Arial" pitchFamily="34" charset="0"/>
+              <a:buChar char="•"/>
+            </a:pPr>
+            <a:r>
+              <a:rPr lang="uz-UZ" sz="1600" dirty="0">
+                <a:latin typeface="Times New Roman" panose="02020603050405020304" pitchFamily="18" charset="0"/>
+                <a:cs typeface="Times New Roman" panose="02020603050405020304" pitchFamily="18" charset="0"/>
+              </a:rPr>
+              <a:t>Korpusda havo balansi muhim: oldingi ventilyatorlar salqin havoni soʻrib oladi, orqadagilar esa issiq havoni haydaydi.</a:t>
             </a:r>
           </a:p>
           <a:p>
@@ -1685,33 +1685,33 @@
                 <a:latin typeface="Times New Roman" panose="02020603050405020304" pitchFamily="18" charset="0"/>
                 <a:cs typeface="Times New Roman" panose="02020603050405020304" pitchFamily="18" charset="0"/>
               </a:rPr>
-              <a:t>Ajralgan issiqlik va chiqarilgan issiqlik o'rtasidagi muvozanat tizim barqaror va samarali ishlashini ta'minlaydi.</a:t>
-            </a:r>
-          </a:p>
-          <a:p>
-            <a:pPr marL="285750" indent="-285750">
-              <a:buFont typeface="Arial" pitchFamily="34" charset="0"/>
-              <a:buChar char="•"/>
-            </a:pPr>
-            <a:r>
-              <a:rPr lang="uz-UZ" sz="1600" dirty="0">
-                <a:latin typeface="Times New Roman" panose="02020603050405020304" pitchFamily="18" charset="0"/>
-                <a:cs typeface="Times New Roman" panose="02020603050405020304" pitchFamily="18" charset="0"/>
-              </a:rPr>
-              <a:t>Sifatli radiator, termopasta va to'g'ri havo oqimi trottlingni oldini oladi va protsessor umrini uzaytiradi.</a:t>
-            </a:r>
-          </a:p>
-          <a:p>
-            <a:pPr marL="285750" indent="-285750">
-              <a:buFont typeface="Arial" pitchFamily="34" charset="0"/>
-              <a:buChar char="•"/>
-            </a:pPr>
-            <a:r>
-              <a:rPr lang="uz-UZ" sz="1600" dirty="0">
-                <a:latin typeface="Times New Roman" panose="02020603050405020304" pitchFamily="18" charset="0"/>
-                <a:cs typeface="Times New Roman" panose="02020603050405020304" pitchFamily="18" charset="0"/>
-              </a:rPr>
-              <a:t>Demak, kompyuterning yuqori unumdorligi to'g'ri tashkil etilgan sovutish tizimiga bevosita bog'liqdir.</a:t>
+              <a:t>Ajralgan issiqlik va chiqarilgan issiqlik oʻrtasidagi muvozanat tizim barqaror va samarali ishlashini taʼminlaydi.</a:t>
+            </a:r>
+          </a:p>
+          <a:p>
+            <a:pPr marL="285750" indent="-285750">
+              <a:buFont typeface="Arial" pitchFamily="34" charset="0"/>
+              <a:buChar char="•"/>
+            </a:pPr>
+            <a:r>
+              <a:rPr lang="uz-UZ" sz="1600" dirty="0">
+                <a:latin typeface="Times New Roman" panose="02020603050405020304" pitchFamily="18" charset="0"/>
+                <a:cs typeface="Times New Roman" panose="02020603050405020304" pitchFamily="18" charset="0"/>
+              </a:rPr>
+              <a:t>Sifatli radiator, termopasta va toʻgʻri havo oqimi trottlingni oldini oladi va protsessor umrini uzaytiradi.</a:t>
+            </a:r>
+          </a:p>
+          <a:p>
+            <a:pPr marL="285750" indent="-285750">
+              <a:buFont typeface="Arial" pitchFamily="34" charset="0"/>
+              <a:buChar char="•"/>
+            </a:pPr>
+            <a:r>
+              <a:rPr lang="uz-UZ" sz="1600" dirty="0">
+                <a:latin typeface="Times New Roman" panose="02020603050405020304" pitchFamily="18" charset="0"/>
+                <a:cs typeface="Times New Roman" panose="02020603050405020304" pitchFamily="18" charset="0"/>
+              </a:rPr>
+              <a:t>Demak, kompyuterning yuqori unumdorligi toʻgʻri tashkil etilgan sovutish tizimiga bevosita bogʻliqdir.</a:t>
             </a:r>
           </a:p>
           <a:p>

</xml_diff>